<commit_message>
small change chunk 8
</commit_message>
<xml_diff>
--- a/Lectures/Chunk 8  - 1D Numpy.pptx
+++ b/Lectures/Chunk 8  - 1D Numpy.pptx
@@ -221,7 +221,7 @@
   <pc:docChgLst>
     <pc:chgData name="Jonathan Bollig" userId="8b5d0afe-f106-45e0-8c3f-fd98fa124db1" providerId="ADAL" clId="{B2469FA9-EBD8-4834-A16D-CBF8EFC907DD}"/>
     <pc:docChg chg="undo custSel addSld delSld modSld">
-      <pc:chgData name="Jonathan Bollig" userId="8b5d0afe-f106-45e0-8c3f-fd98fa124db1" providerId="ADAL" clId="{B2469FA9-EBD8-4834-A16D-CBF8EFC907DD}" dt="2025-10-07T00:02:27.634" v="3072" actId="20577"/>
+      <pc:chgData name="Jonathan Bollig" userId="8b5d0afe-f106-45e0-8c3f-fd98fa124db1" providerId="ADAL" clId="{B2469FA9-EBD8-4834-A16D-CBF8EFC907DD}" dt="2025-10-07T16:25:25.139" v="3087" actId="20577"/>
       <pc:docMkLst>
         <pc:docMk/>
       </pc:docMkLst>
@@ -557,13 +557,13 @@
         </pc:sldMkLst>
       </pc:sldChg>
       <pc:sldChg chg="modSp new mod">
-        <pc:chgData name="Jonathan Bollig" userId="8b5d0afe-f106-45e0-8c3f-fd98fa124db1" providerId="ADAL" clId="{B2469FA9-EBD8-4834-A16D-CBF8EFC907DD}" dt="2025-10-05T11:02:02.503" v="3021" actId="20577"/>
+        <pc:chgData name="Jonathan Bollig" userId="8b5d0afe-f106-45e0-8c3f-fd98fa124db1" providerId="ADAL" clId="{B2469FA9-EBD8-4834-A16D-CBF8EFC907DD}" dt="2025-10-07T16:25:25.139" v="3087" actId="20577"/>
         <pc:sldMkLst>
           <pc:docMk/>
           <pc:sldMk cId="2146985610" sldId="276"/>
         </pc:sldMkLst>
         <pc:spChg chg="mod">
-          <ac:chgData name="Jonathan Bollig" userId="8b5d0afe-f106-45e0-8c3f-fd98fa124db1" providerId="ADAL" clId="{B2469FA9-EBD8-4834-A16D-CBF8EFC907DD}" dt="2025-10-05T11:02:02.503" v="3021" actId="20577"/>
+          <ac:chgData name="Jonathan Bollig" userId="8b5d0afe-f106-45e0-8c3f-fd98fa124db1" providerId="ADAL" clId="{B2469FA9-EBD8-4834-A16D-CBF8EFC907DD}" dt="2025-10-07T16:25:25.139" v="3087" actId="20577"/>
           <ac:spMkLst>
             <pc:docMk/>
             <pc:sldMk cId="2146985610" sldId="276"/>
@@ -5874,7 +5874,7 @@
           <a:p>
             <a:r>
               <a:rPr lang="en-US" dirty="0"/>
-              <a:t>Array Generation Functions</a:t>
+              <a:t>Live Coding: Array Generation Functions</a:t>
             </a:r>
             <a:endParaRPr lang="de-DE" dirty="0"/>
           </a:p>

</xml_diff>